<commit_message>
Update 시간 맞추기 assets and add ZIP slides
Co-Authored-By: Claude Opus 4.6 (1M context) <noreply@anthropic.com>
</commit_message>
<xml_diff>
--- a/public/downloads/games/time-match/rules.pptx
+++ b/public/downloads/games/time-match/rules.pptx
@@ -14,16 +14,12 @@
   <p:notesSz cx="6858000" cy="9144000"/>
   <p:embeddedFontLst>
     <p:embeddedFont>
-      <p:font typeface="Jua" charset="1" panose="00000000000000000000"/>
+      <p:font typeface="무궁화 고딕" charset="1" panose="02020603020101020101"/>
       <p:regular r:id="rId10"/>
     </p:embeddedFont>
     <p:embeddedFont>
-      <p:font typeface="TDTD갬성명조" charset="1" panose="02000503000000000000"/>
+      <p:font typeface="무궁화 고딕 Bold" charset="1" panose="02020603020101020101"/>
       <p:regular r:id="rId11"/>
-    </p:embeddedFont>
-    <p:embeddedFont>
-      <p:font typeface="TDTD가온" charset="1" panose="02000503000000000000"/>
-      <p:regular r:id="rId12"/>
     </p:embeddedFont>
   </p:embeddedFontLst>
   <p:defaultTextStyle>
@@ -3141,8 +3137,8 @@
         </p:nvSpPr>
         <p:spPr>
           <a:xfrm rot="0">
-            <a:off x="1028700" y="3892867"/>
-            <a:ext cx="15555091" cy="2200275"/>
+            <a:off x="1028700" y="4178617"/>
+            <a:ext cx="15555091" cy="1914525"/>
           </a:xfrm>
           <a:prstGeom prst="rect">
             <a:avLst/>
@@ -3164,10 +3160,10 @@
                 <a:solidFill>
                   <a:srgbClr val="FFFAEF"/>
                 </a:solidFill>
-                <a:latin typeface="Jua"/>
-                <a:ea typeface="Jua"/>
-                <a:cs typeface="Jua"/>
-                <a:sym typeface="Jua"/>
+                <a:latin typeface="무궁화 고딕"/>
+                <a:ea typeface="무궁화 고딕"/>
+                <a:cs typeface="무궁화 고딕"/>
+                <a:sym typeface="무궁화 고딕"/>
               </a:rPr>
               <a:t>시간 맞추기</a:t>
             </a:r>
@@ -3182,8 +3178,8 @@
         </p:nvSpPr>
         <p:spPr>
           <a:xfrm rot="0">
-            <a:off x="15264803" y="9812655"/>
-            <a:ext cx="2637975" cy="474345"/>
+            <a:off x="14121803" y="9822180"/>
+            <a:ext cx="3780975" cy="464820"/>
           </a:xfrm>
           <a:prstGeom prst="rect">
             <a:avLst/>
@@ -3208,10 +3204,10 @@
                 <a:solidFill>
                   <a:srgbClr val="FFFFFF"/>
                 </a:solidFill>
-                <a:latin typeface="TDTD갬성명조"/>
-                <a:ea typeface="TDTD갬성명조"/>
-                <a:cs typeface="TDTD갬성명조"/>
-                <a:sym typeface="TDTD갬성명조"/>
+                <a:latin typeface="무궁화 고딕"/>
+                <a:ea typeface="무궁화 고딕"/>
+                <a:cs typeface="무궁화 고딕"/>
+                <a:sym typeface="무궁화 고딕"/>
               </a:rPr>
               <a:t>ⓒ 2026. Sunday Play</a:t>
             </a:r>
@@ -3360,8 +3356,8 @@
         </p:nvSpPr>
         <p:spPr>
           <a:xfrm rot="0">
-            <a:off x="11392761" y="600705"/>
-            <a:ext cx="5362043" cy="1600200"/>
+            <a:off x="11392761" y="819780"/>
+            <a:ext cx="5362043" cy="1381125"/>
           </a:xfrm>
           <a:prstGeom prst="rect">
             <a:avLst/>
@@ -3383,10 +3379,10 @@
                 <a:solidFill>
                   <a:srgbClr val="FFFAEF"/>
                 </a:solidFill>
-                <a:latin typeface="Jua"/>
-                <a:ea typeface="Jua"/>
-                <a:cs typeface="Jua"/>
-                <a:sym typeface="Jua"/>
+                <a:latin typeface="무궁화 고딕"/>
+                <a:ea typeface="무궁화 고딕"/>
+                <a:cs typeface="무궁화 고딕"/>
+                <a:sym typeface="무궁화 고딕"/>
               </a:rPr>
               <a:t>규칙</a:t>
             </a:r>
@@ -3402,9 +3398,9 @@
         <p:grpSpPr>
           <a:xfrm rot="0">
             <a:off x="309172" y="535073"/>
-            <a:ext cx="12619696" cy="2100123"/>
+            <a:ext cx="12619696" cy="1929563"/>
             <a:chOff x="0" y="0"/>
-            <a:chExt cx="16826261" cy="2800164"/>
+            <a:chExt cx="16826261" cy="2572751"/>
           </a:xfrm>
         </p:grpSpPr>
         <p:sp>
@@ -3415,8 +3411,8 @@
           </p:nvSpPr>
           <p:spPr>
             <a:xfrm rot="0">
-              <a:off x="0" y="1615940"/>
-              <a:ext cx="16826261" cy="1184224"/>
+              <a:off x="0" y="1638666"/>
+              <a:ext cx="16826261" cy="934085"/>
             </a:xfrm>
             <a:prstGeom prst="rect">
               <a:avLst/>
@@ -3430,18 +3426,18 @@
             <a:p>
               <a:pPr algn="l">
                 <a:lnSpc>
-                  <a:spcPts val="7402"/>
+                  <a:spcPts val="5880"/>
                 </a:lnSpc>
               </a:pPr>
               <a:r>
-                <a:rPr lang="en-US" sz="5287">
+                <a:rPr lang="en-US" sz="4200">
                   <a:solidFill>
                     <a:srgbClr val="FFFAEF"/>
                   </a:solidFill>
-                  <a:latin typeface="TDTD가온"/>
-                  <a:ea typeface="TDTD가온"/>
-                  <a:cs typeface="TDTD가온"/>
-                  <a:sym typeface="TDTD가온"/>
+                  <a:latin typeface="무궁화 고딕"/>
+                  <a:ea typeface="무궁화 고딕"/>
+                  <a:cs typeface="무궁화 고딕"/>
+                  <a:sym typeface="무궁화 고딕"/>
                 </a:rPr>
                 <a:t>목표 시간을 정합니다. (예: 10초)</a:t>
               </a:r>
@@ -3456,8 +3452,8 @@
           </p:nvSpPr>
           <p:spPr>
             <a:xfrm rot="0">
-              <a:off x="0" y="-190500"/>
-              <a:ext cx="11298371" cy="1367863"/>
+              <a:off x="0" y="-66675"/>
+              <a:ext cx="11298371" cy="1238189"/>
             </a:xfrm>
             <a:prstGeom prst="rect">
               <a:avLst/>
@@ -3479,10 +3475,10 @@
                   <a:solidFill>
                     <a:srgbClr val="FFFAEF"/>
                   </a:solidFill>
-                  <a:latin typeface="Jua"/>
-                  <a:ea typeface="Jua"/>
-                  <a:cs typeface="Jua"/>
-                  <a:sym typeface="Jua"/>
+                  <a:latin typeface="무궁화 고딕 Bold"/>
+                  <a:ea typeface="무궁화 고딕 Bold"/>
+                  <a:cs typeface="무궁화 고딕 Bold"/>
+                  <a:sym typeface="무궁화 고딕 Bold"/>
                 </a:rPr>
                 <a:t>STEP 1.</a:t>
               </a:r>
@@ -3499,9 +3495,9 @@
         <p:grpSpPr>
           <a:xfrm rot="0">
             <a:off x="11875494" y="7319033"/>
-            <a:ext cx="6412506" cy="2967967"/>
+            <a:ext cx="6412506" cy="2614907"/>
             <a:chOff x="0" y="0"/>
-            <a:chExt cx="8550008" cy="3957289"/>
+            <a:chExt cx="8550008" cy="3486543"/>
           </a:xfrm>
         </p:grpSpPr>
         <p:sp>
@@ -3512,8 +3508,8 @@
           </p:nvSpPr>
           <p:spPr>
             <a:xfrm rot="0">
-              <a:off x="0" y="1542808"/>
-              <a:ext cx="8468722" cy="2414482"/>
+              <a:off x="0" y="1561858"/>
+              <a:ext cx="8468722" cy="1924685"/>
             </a:xfrm>
             <a:prstGeom prst="rect">
               <a:avLst/>
@@ -3527,18 +3523,18 @@
             <a:p>
               <a:pPr algn="l">
                 <a:lnSpc>
-                  <a:spcPts val="7420"/>
+                  <a:spcPts val="5880"/>
                 </a:lnSpc>
               </a:pPr>
               <a:r>
-                <a:rPr lang="en-US" sz="5300">
+                <a:rPr lang="en-US" sz="4200">
                   <a:solidFill>
                     <a:srgbClr val="FFFAEF"/>
                   </a:solidFill>
-                  <a:latin typeface="TDTD가온"/>
-                  <a:ea typeface="TDTD가온"/>
-                  <a:cs typeface="TDTD가온"/>
-                  <a:sym typeface="TDTD가온"/>
+                  <a:latin typeface="무궁화 고딕"/>
+                  <a:ea typeface="무궁화 고딕"/>
+                  <a:cs typeface="무궁화 고딕"/>
+                  <a:sym typeface="무궁화 고딕"/>
                 </a:rPr>
                 <a:t>목표 시간과 가장 가깝게</a:t>
               </a:r>
@@ -3546,18 +3542,18 @@
             <a:p>
               <a:pPr algn="l">
                 <a:lnSpc>
-                  <a:spcPts val="7420"/>
+                  <a:spcPts val="5880"/>
                 </a:lnSpc>
               </a:pPr>
               <a:r>
-                <a:rPr lang="en-US" sz="5300">
+                <a:rPr lang="en-US" sz="4200">
                   <a:solidFill>
                     <a:srgbClr val="FFFAEF"/>
                   </a:solidFill>
-                  <a:latin typeface="TDTD가온"/>
-                  <a:ea typeface="TDTD가온"/>
-                  <a:cs typeface="TDTD가온"/>
-                  <a:sym typeface="TDTD가온"/>
+                  <a:latin typeface="무궁화 고딕"/>
+                  <a:ea typeface="무궁화 고딕"/>
+                  <a:cs typeface="무궁화 고딕"/>
+                  <a:sym typeface="무궁화 고딕"/>
                 </a:rPr>
                 <a:t>멈춘 사람이 우승!</a:t>
               </a:r>
@@ -3572,8 +3568,8 @@
           </p:nvSpPr>
           <p:spPr>
             <a:xfrm rot="0">
-              <a:off x="0" y="-190500"/>
-              <a:ext cx="8550008" cy="1374479"/>
+              <a:off x="0" y="-57150"/>
+              <a:ext cx="8550008" cy="1241129"/>
             </a:xfrm>
             <a:prstGeom prst="rect">
               <a:avLst/>
@@ -3595,10 +3591,10 @@
                   <a:solidFill>
                     <a:srgbClr val="FFFAEF"/>
                   </a:solidFill>
-                  <a:latin typeface="Jua"/>
-                  <a:ea typeface="Jua"/>
-                  <a:cs typeface="Jua"/>
-                  <a:sym typeface="Jua"/>
+                  <a:latin typeface="무궁화 고딕 Bold"/>
+                  <a:ea typeface="무궁화 고딕 Bold"/>
+                  <a:cs typeface="무궁화 고딕 Bold"/>
+                  <a:sym typeface="무궁화 고딕 Bold"/>
                 </a:rPr>
                 <a:t>STEP 3.</a:t>
               </a:r>
@@ -3615,9 +3611,9 @@
         <p:grpSpPr>
           <a:xfrm rot="0">
             <a:off x="3927128" y="3458624"/>
-            <a:ext cx="11787343" cy="3036981"/>
+            <a:ext cx="11787343" cy="2667951"/>
             <a:chOff x="0" y="0"/>
-            <a:chExt cx="15716458" cy="4049308"/>
+            <a:chExt cx="15716458" cy="3557269"/>
           </a:xfrm>
         </p:grpSpPr>
         <p:sp>
@@ -3628,8 +3624,8 @@
           </p:nvSpPr>
           <p:spPr>
             <a:xfrm rot="0">
-              <a:off x="0" y="1621596"/>
-              <a:ext cx="15716458" cy="2427712"/>
+              <a:off x="0" y="1632584"/>
+              <a:ext cx="15716458" cy="1924685"/>
             </a:xfrm>
             <a:prstGeom prst="rect">
               <a:avLst/>
@@ -3643,18 +3639,18 @@
             <a:p>
               <a:pPr algn="l">
                 <a:lnSpc>
-                  <a:spcPts val="7415"/>
+                  <a:spcPts val="5880"/>
                 </a:lnSpc>
               </a:pPr>
               <a:r>
-                <a:rPr lang="en-US" sz="5296">
+                <a:rPr lang="en-US" sz="4200">
                   <a:solidFill>
                     <a:srgbClr val="FFFAEF"/>
                   </a:solidFill>
-                  <a:latin typeface="TDTD가온"/>
-                  <a:ea typeface="TDTD가온"/>
-                  <a:cs typeface="TDTD가온"/>
-                  <a:sym typeface="TDTD가온"/>
+                  <a:latin typeface="무궁화 고딕"/>
+                  <a:ea typeface="무궁화 고딕"/>
+                  <a:cs typeface="무궁화 고딕"/>
+                  <a:sym typeface="무궁화 고딕"/>
                 </a:rPr>
                 <a:t>타이머를 시작하고 화면을 보지 마세요!</a:t>
               </a:r>
@@ -3662,18 +3658,18 @@
             <a:p>
               <a:pPr algn="l">
                 <a:lnSpc>
-                  <a:spcPts val="7415"/>
+                  <a:spcPts val="5880"/>
                 </a:lnSpc>
               </a:pPr>
               <a:r>
-                <a:rPr lang="en-US" sz="5296">
+                <a:rPr lang="en-US" sz="4200">
                   <a:solidFill>
                     <a:srgbClr val="FFFAEF"/>
                   </a:solidFill>
-                  <a:latin typeface="TDTD가온"/>
-                  <a:ea typeface="TDTD가온"/>
-                  <a:cs typeface="TDTD가온"/>
-                  <a:sym typeface="TDTD가온"/>
+                  <a:latin typeface="무궁화 고딕"/>
+                  <a:ea typeface="무궁화 고딕"/>
+                  <a:cs typeface="무궁화 고딕"/>
+                  <a:sym typeface="무궁화 고딕"/>
                 </a:rPr>
                 <a:t>목표 시간이 되었다고 생각하면 "스탑"하세요</a:t>
               </a:r>
@@ -3688,8 +3684,8 @@
           </p:nvSpPr>
           <p:spPr>
             <a:xfrm rot="0">
-              <a:off x="0" y="-190500"/>
-              <a:ext cx="5799240" cy="1369906"/>
+              <a:off x="0" y="-66675"/>
+              <a:ext cx="5799240" cy="1238018"/>
             </a:xfrm>
             <a:prstGeom prst="rect">
               <a:avLst/>
@@ -3711,10 +3707,10 @@
                   <a:solidFill>
                     <a:srgbClr val="FFFAEF"/>
                   </a:solidFill>
-                  <a:latin typeface="Jua"/>
-                  <a:ea typeface="Jua"/>
-                  <a:cs typeface="Jua"/>
-                  <a:sym typeface="Jua"/>
+                  <a:latin typeface="무궁화 고딕 Bold"/>
+                  <a:ea typeface="무궁화 고딕 Bold"/>
+                  <a:cs typeface="무궁화 고딕 Bold"/>
+                  <a:sym typeface="무궁화 고딕 Bold"/>
                 </a:rPr>
                 <a:t>STEP 2.</a:t>
               </a:r>
@@ -3812,8 +3808,8 @@
         </p:nvSpPr>
         <p:spPr>
           <a:xfrm rot="0">
-            <a:off x="1028700" y="3892867"/>
-            <a:ext cx="15555091" cy="2200275"/>
+            <a:off x="1028700" y="4178617"/>
+            <a:ext cx="15555091" cy="1914525"/>
           </a:xfrm>
           <a:prstGeom prst="rect">
             <a:avLst/>
@@ -3835,10 +3831,10 @@
                 <a:solidFill>
                   <a:srgbClr val="FFFAEF"/>
                 </a:solidFill>
-                <a:latin typeface="Jua"/>
-                <a:ea typeface="Jua"/>
-                <a:cs typeface="Jua"/>
-                <a:sym typeface="Jua"/>
+                <a:latin typeface="무궁화 고딕"/>
+                <a:ea typeface="무궁화 고딕"/>
+                <a:cs typeface="무궁화 고딕"/>
+                <a:sym typeface="무궁화 고딕"/>
               </a:rPr>
               <a:t>시간 맞추기</a:t>
             </a:r>
@@ -3853,8 +3849,8 @@
         </p:nvSpPr>
         <p:spPr>
           <a:xfrm rot="0">
-            <a:off x="15264803" y="9812655"/>
-            <a:ext cx="2637975" cy="474345"/>
+            <a:off x="14121803" y="9822180"/>
+            <a:ext cx="3780975" cy="464820"/>
           </a:xfrm>
           <a:prstGeom prst="rect">
             <a:avLst/>
@@ -3879,10 +3875,10 @@
                 <a:solidFill>
                   <a:srgbClr val="FFFFFF"/>
                 </a:solidFill>
-                <a:latin typeface="TDTD갬성명조"/>
-                <a:ea typeface="TDTD갬성명조"/>
-                <a:cs typeface="TDTD갬성명조"/>
-                <a:sym typeface="TDTD갬성명조"/>
+                <a:latin typeface="무궁화 고딕"/>
+                <a:ea typeface="무궁화 고딕"/>
+                <a:cs typeface="무궁화 고딕"/>
+                <a:sym typeface="무궁화 고딕"/>
               </a:rPr>
               <a:t>ⓒ 2026. Sunday Play</a:t>
             </a:r>
@@ -3954,8 +3950,8 @@
         </p:nvSpPr>
         <p:spPr>
           <a:xfrm rot="0">
-            <a:off x="4421807" y="3895725"/>
-            <a:ext cx="9444385" cy="2200275"/>
+            <a:off x="4421807" y="4181475"/>
+            <a:ext cx="9444385" cy="1914525"/>
           </a:xfrm>
           <a:prstGeom prst="rect">
             <a:avLst/>
@@ -3977,10 +3973,10 @@
                 <a:solidFill>
                   <a:srgbClr val="000000"/>
                 </a:solidFill>
-                <a:latin typeface="Jua"/>
-                <a:ea typeface="Jua"/>
-                <a:cs typeface="Jua"/>
-                <a:sym typeface="Jua"/>
+                <a:latin typeface="무궁화 고딕"/>
+                <a:ea typeface="무궁화 고딕"/>
+                <a:cs typeface="무궁화 고딕"/>
+                <a:sym typeface="무궁화 고딕"/>
               </a:rPr>
               <a:t>감사합니다!</a:t>
             </a:r>

</xml_diff>